<commit_message>
docs: slide e scaletta aggiornate con il lavoro dello Sprint 2 #92
</commit_message>
<xml_diff>
--- a/docs/presentation-slides.pptx
+++ b/docs/presentation-slides.pptx
@@ -864,7 +864,7 @@
           <a:p>
             <a:r>
               <a:rPr lang="en-US" dirty="0"/>
-              <a:t>1 minuto (asprenolapo). Elencare solo ciò che il PO ha deciso: il registro è docs/analysis/po-decisions.md. Le righe ancora in attesa vanno chiuse prima di presentare. Telefono e anticipo massimo: da confermare.</a:t>
+              <a:t>1 minuto (asprenolapo). Elencare solo ciò che il PO ha deciso: il registro è docs/analysis/po-decisions.md. Le righe ancora in attesa vanno chiuse prima di presentare. Anticipo massimo di una prenotazione: non deciso.</a:t>
             </a:r>
             <a:endParaRPr lang="en-US" dirty="0"/>
           </a:p>
@@ -952,7 +952,7 @@
           <a:p>
             <a:r>
               <a:rPr lang="en-US" dirty="0"/>
-              <a:t>2 minuti, insieme alla slide successiva. Un database per servizio: nessuna query unisce MongoDB e PostgreSQL. Bookings salva una copia di nome, tipo ed edificio dello spazio e chiede a Spaces i dati attuali con REST e timeout. Dettagli e pro e contro in docs/architecture.md.</a:t>
+              <a:t>2 minuti, insieme alla slide successiva. Un database per servizio: nessuna query unisce MongoDB e PostgreSQL. Bookings salva una copia di nome, tipo ed edificio dello spazio e chiede a Spaces i dati attuali con REST e timeout. Dettagli e pro e contro in docs/architecture.md e negli ADR di docs/decisions/.</a:t>
             </a:r>
             <a:endParaRPr lang="en-US" dirty="0"/>
           </a:p>
@@ -1040,7 +1040,7 @@
           <a:p>
             <a:r>
               <a:rPr lang="en-US" dirty="0"/>
-              <a:t>Continua dalla slide precedente. Dire il perché di ogni scelta e il compromesso accettato. Le scelte D1-D10 con pro e contro sono in docs/architecture.md; il PO non ha ancora validato tutto.</a:t>
+              <a:t>Continua dalla slide precedente. Dire il perché di ogni scelta e il compromesso accettato. Le decisioni D1-D10 con pro e contro sono in docs/architecture.md e negli ADR di docs/decisions/.</a:t>
             </a:r>
             <a:endParaRPr lang="en-US" dirty="0"/>
           </a:p>
@@ -1216,7 +1216,7 @@
           <a:p>
             <a:r>
               <a:rPr lang="en-US" dirty="0"/>
-              <a:t>4 minuti, una parte ciascuno. Percorso su dati sintetici caricati dal seed (SC-SEED-*, vedi data/synthetic/bookings-seed.md). Aggiungere, quando pronti e provati, il login, i gruppi con inviti e la vista admin. Il percorso va provato a voce da tutto il gruppo almeno una volta.</a:t>
+              <a:t>4 minuti, una parte ciascuno. Il percorso completo, con 15 passi e l'esito atteso di ognuno, è in docs/demo-path.md; il 28/10 è stato eseguito sull'API con gli esiti attesi (docs/evidence/2026-10-28-demo-rehearsal-api.md). Va ancora provato nell'interfaccia e a voce da tutto il gruppo.</a:t>
             </a:r>
             <a:endParaRPr lang="en-US" dirty="0"/>
           </a:p>
@@ -1304,7 +1304,7 @@
           <a:p>
             <a:r>
               <a:rPr lang="en-US" dirty="0"/>
-              <a:t>2 minuti (Rhaastrake, FranDeSa456). Citare solo ciò che è stato eseguito, con l'esito vero: la concorrenza sull'aula mista è superata in locale ma in CI c'e stato un fallimento (issue 142, ancora in indagine). Evidenze in docs/evidence/ e nei test di tests/SmartCampus.Bookings.Tests.</a:t>
+              <a:t>2 minuti (Rhaastrake, FranDeSa456). Citare solo ciò che è stato eseguito, con l'esito vero. La concorrenza sull'aula mista è superata in locale; in CI c'è stato un solo fallimento, non riprodotto in 80 esecuzioni (issue 142, chiusa con un'ipotesi). Evidenze in docs/evidence/ e nei test di tests/SmartCampus.Bookings.Tests. Il percorso della demo è stato provato solo sull'API.</a:t>
             </a:r>
             <a:endParaRPr lang="en-US" dirty="0"/>
           </a:p>
@@ -2141,7 +2141,7 @@
       </p:sp>
       <p:sp>
         <p:nvSpPr>
-          <p:cNvPr id="4" name="card-92"/>
+          <p:cNvPr id="4" name="card-100"/>
           <p:cNvSpPr/>
           <p:nvPr/>
         </p:nvSpPr>
@@ -2166,7 +2166,7 @@
       </p:sp>
       <p:sp>
         <p:nvSpPr>
-          <p:cNvPr id="5" name="card-93"/>
+          <p:cNvPr id="5" name="card-101"/>
           <p:cNvSpPr/>
           <p:nvPr/>
         </p:nvSpPr>
@@ -2191,7 +2191,7 @@
       </p:sp>
       <p:sp>
         <p:nvSpPr>
-          <p:cNvPr id="6" name="text-94"/>
+          <p:cNvPr id="6" name="text-102"/>
           <p:cNvSpPr txBox="1"/>
           <p:nvPr/>
         </p:nvSpPr>
@@ -2230,7 +2230,7 @@
       </p:sp>
       <p:sp>
         <p:nvSpPr>
-          <p:cNvPr id="7" name="text-95"/>
+          <p:cNvPr id="7" name="text-103"/>
           <p:cNvSpPr txBox="1"/>
           <p:nvPr/>
         </p:nvSpPr>
@@ -2269,7 +2269,7 @@
       </p:sp>
       <p:sp>
         <p:nvSpPr>
-          <p:cNvPr id="8" name="text-96"/>
+          <p:cNvPr id="8" name="text-104"/>
           <p:cNvSpPr txBox="1"/>
           <p:nvPr/>
         </p:nvSpPr>
@@ -2308,7 +2308,7 @@
       </p:sp>
       <p:sp>
         <p:nvSpPr>
-          <p:cNvPr id="9" name="text-97"/>
+          <p:cNvPr id="9" name="text-105"/>
           <p:cNvSpPr txBox="1"/>
           <p:nvPr/>
         </p:nvSpPr>
@@ -2525,7 +2525,7 @@
       </p:sp>
       <p:graphicFrame>
         <p:nvGraphicFramePr>
-          <p:cNvPr id="12" name="table-98"/>
+          <p:cNvPr id="12" name="table-106"/>
           <p:cNvGraphicFramePr>
             <a:graphicFrameLocks noGrp="1"/>
           </p:cNvGraphicFramePr>
@@ -2632,7 +2632,7 @@
                           <a:ea typeface="Calibri" pitchFamily="34" charset="-122"/>
                           <a:cs typeface="Calibri" pitchFamily="34" charset="-120"/>
                         </a:rPr>
-                        <a:t>Piattaforma: soluzione, Docker Compose, CI, verifica del token; incontro con il PO</a:t>
+                        <a:t>Piattaforma: soluzione, Docker Compose, CI, controllo PR, flusso agentico, ADR</a:t>
                       </a:r>
                       <a:endParaRPr lang="en-US" sz="1400" dirty="0">
                         <a:latin typeface="Calibri" charset="0"/>
@@ -2764,7 +2764,7 @@
                           <a:ea typeface="Calibri" pitchFamily="34" charset="-122"/>
                           <a:cs typeface="Calibri" pitchFamily="34" charset="-120"/>
                         </a:rPr>
-                        <a:t>Spaces su MongoDB: catalogo, indisponibilità, strumenti</a:t>
+                        <a:t>Spaces su MongoDB: catalogo, ricerca, indisponibilità, strumenti</a:t>
                       </a:r>
                       <a:endParaRPr lang="en-US" sz="1400" dirty="0">
                         <a:latin typeface="Calibri" charset="0"/>
@@ -2896,7 +2896,7 @@
                           <a:ea typeface="Calibri" pitchFamily="34" charset="-122"/>
                           <a:cs typeface="Calibri" pitchFamily="34" charset="-120"/>
                         </a:rPr>
-                        <a:t>Bookings: schema, creazione, annullamento, vincoli, aule miste, orari, seed</a:t>
+                        <a:t>Bookings: schema, creazione, annullamento, vincoli, aule miste, fasce orarie, seed</a:t>
                       </a:r>
                       <a:endParaRPr lang="en-US" sz="1400" dirty="0">
                         <a:latin typeface="Calibri" charset="0"/>
@@ -3028,7 +3028,7 @@
                           <a:ea typeface="Calibri" pitchFamily="34" charset="-122"/>
                           <a:cs typeface="Calibri" pitchFamily="34" charset="-120"/>
                         </a:rPr>
-                        <a:t>Bookings: inviti, email, mie prenotazioni, test di concorrenza</a:t>
+                        <a:t>Bookings: gruppi, inviti, scadenza, email, mie prenotazioni, disponibilità</a:t>
                       </a:r>
                       <a:endParaRPr lang="en-US" sz="1400" dirty="0">
                         <a:latin typeface="Calibri" charset="0"/>
@@ -3160,7 +3160,7 @@
                           <a:ea typeface="Calibri" pitchFamily="34" charset="-122"/>
                           <a:cs typeface="Calibri" pitchFamily="34" charset="-120"/>
                         </a:rPr>
-                        <a:t>Users e accesso, commento finale, dati sintetici</a:t>
+                        <a:t>Users e accesso, commento finale, dati sintetici, disponibilità</a:t>
                       </a:r>
                       <a:endParaRPr lang="en-US" sz="1400" dirty="0">
                         <a:latin typeface="Calibri" charset="0"/>
@@ -3292,7 +3292,7 @@
                           <a:ea typeface="Calibri" pitchFamily="34" charset="-122"/>
                           <a:cs typeface="Calibri" pitchFamily="34" charset="-120"/>
                         </a:rPr>
-                        <a:t>Area admin: dashboard, avvisi, eccezioni</a:t>
+                        <a:t>Area admin: dashboard, avvisi, eccezioni, statistiche d'uso</a:t>
                       </a:r>
                       <a:endParaRPr lang="en-US" sz="1400" dirty="0">
                         <a:latin typeface="Calibri" charset="0"/>
@@ -3424,7 +3424,7 @@
                           <a:ea typeface="Calibri" pitchFamily="34" charset="-122"/>
                           <a:cs typeface="Calibri" pitchFamily="34" charset="-120"/>
                         </a:rPr>
-                        <a:t>Frontend utente: accesso, prenotazione, gestione errori</a:t>
+                        <a:t>Frontend utente: accesso, registrazione, prenotazione, gestione errori</a:t>
                       </a:r>
                       <a:endParaRPr lang="en-US" sz="1400" dirty="0">
                         <a:latin typeface="Calibri" charset="0"/>
@@ -7064,8 +7064,8 @@
         </p:nvSpPr>
         <p:spPr>
           <a:xfrm>
-            <a:off x="457200" y="1280160"/>
-            <a:ext cx="4023360" cy="1005840"/>
+            <a:off x="457200" y="1143000"/>
+            <a:ext cx="4023360" cy="777240"/>
           </a:xfrm>
           <a:prstGeom prst="rect">
             <a:avLst/>
@@ -7089,8 +7089,8 @@
         </p:nvSpPr>
         <p:spPr>
           <a:xfrm>
-            <a:off x="640080" y="1463040"/>
-            <a:ext cx="548640" cy="640080"/>
+            <a:off x="640080" y="1234440"/>
+            <a:ext cx="548640" cy="594360"/>
           </a:xfrm>
           <a:prstGeom prst="rect">
             <a:avLst/>
@@ -7106,7 +7106,7 @@
               <a:buNone/>
             </a:pPr>
             <a:r>
-              <a:rPr lang="en-US" sz="3600" b="1" dirty="0">
+              <a:rPr lang="en-US" sz="3000" b="1" dirty="0">
                 <a:solidFill>
                   <a:schemeClr val="accent2"/>
                 </a:solidFill>
@@ -7116,7 +7116,7 @@
               </a:rPr>
               <a:t>1</a:t>
             </a:r>
-            <a:endParaRPr lang="en-US" sz="3600" dirty="0"/>
+            <a:endParaRPr lang="en-US" sz="3000" dirty="0"/>
           </a:p>
         </p:txBody>
       </p:sp>
@@ -7128,8 +7128,8 @@
         </p:nvSpPr>
         <p:spPr>
           <a:xfrm>
-            <a:off x="1325880" y="1389888"/>
-            <a:ext cx="3017520" cy="329184"/>
+            <a:off x="1325880" y="1207008"/>
+            <a:ext cx="3017520" cy="292608"/>
           </a:xfrm>
           <a:prstGeom prst="rect">
             <a:avLst/>
@@ -7145,7 +7145,7 @@
               <a:buNone/>
             </a:pPr>
             <a:r>
-              <a:rPr lang="en-US" sz="1800" b="1" dirty="0">
+              <a:rPr lang="en-US" sz="1600" b="1" dirty="0">
                 <a:solidFill>
                   <a:schemeClr val="tx2"/>
                 </a:solidFill>
@@ -7155,7 +7155,7 @@
               </a:rPr>
               <a:t>Prenotare</a:t>
             </a:r>
-            <a:endParaRPr lang="en-US" sz="1800" dirty="0"/>
+            <a:endParaRPr lang="en-US" sz="1600" dirty="0"/>
           </a:p>
         </p:txBody>
       </p:sp>
@@ -7167,8 +7167,8 @@
         </p:nvSpPr>
         <p:spPr>
           <a:xfrm>
-            <a:off x="1325880" y="1737360"/>
-            <a:ext cx="3017520" cy="502920"/>
+            <a:off x="1325880" y="1508760"/>
+            <a:ext cx="3017520" cy="384048"/>
           </a:xfrm>
           <a:prstGeom prst="rect">
             <a:avLst/>
@@ -7184,7 +7184,7 @@
               <a:buNone/>
             </a:pPr>
             <a:r>
-              <a:rPr lang="en-US" sz="1400" dirty="0">
+              <a:rPr lang="en-US" sz="1200" dirty="0">
                 <a:solidFill>
                   <a:schemeClr val="tx1"/>
                 </a:solidFill>
@@ -7194,7 +7194,7 @@
               </a:rPr>
               <a:t>Aula 101 in una fascia libera: conferma con codice leggibile</a:t>
             </a:r>
-            <a:endParaRPr lang="en-US" sz="1400" dirty="0"/>
+            <a:endParaRPr lang="en-US" sz="1200" dirty="0"/>
           </a:p>
         </p:txBody>
       </p:sp>
@@ -7206,8 +7206,8 @@
         </p:nvSpPr>
         <p:spPr>
           <a:xfrm>
-            <a:off x="4663440" y="1280160"/>
-            <a:ext cx="4023360" cy="1005840"/>
+            <a:off x="4663440" y="1143000"/>
+            <a:ext cx="4023360" cy="777240"/>
           </a:xfrm>
           <a:prstGeom prst="rect">
             <a:avLst/>
@@ -7231,8 +7231,8 @@
         </p:nvSpPr>
         <p:spPr>
           <a:xfrm>
-            <a:off x="4846320" y="1463040"/>
-            <a:ext cx="548640" cy="640080"/>
+            <a:off x="4846320" y="1234440"/>
+            <a:ext cx="548640" cy="594360"/>
           </a:xfrm>
           <a:prstGeom prst="rect">
             <a:avLst/>
@@ -7248,7 +7248,7 @@
               <a:buNone/>
             </a:pPr>
             <a:r>
-              <a:rPr lang="en-US" sz="3600" b="1" dirty="0">
+              <a:rPr lang="en-US" sz="3000" b="1" dirty="0">
                 <a:solidFill>
                   <a:schemeClr val="accent2"/>
                 </a:solidFill>
@@ -7258,7 +7258,7 @@
               </a:rPr>
               <a:t>2</a:t>
             </a:r>
-            <a:endParaRPr lang="en-US" sz="3600" dirty="0"/>
+            <a:endParaRPr lang="en-US" sz="3000" dirty="0"/>
           </a:p>
         </p:txBody>
       </p:sp>
@@ -7270,8 +7270,8 @@
         </p:nvSpPr>
         <p:spPr>
           <a:xfrm>
-            <a:off x="5532120" y="1389888"/>
-            <a:ext cx="3017520" cy="329184"/>
+            <a:off x="5532120" y="1207008"/>
+            <a:ext cx="3017520" cy="292608"/>
           </a:xfrm>
           <a:prstGeom prst="rect">
             <a:avLst/>
@@ -7287,7 +7287,7 @@
               <a:buNone/>
             </a:pPr>
             <a:r>
-              <a:rPr lang="en-US" sz="1800" b="1" dirty="0">
+              <a:rPr lang="en-US" sz="1600" b="1" dirty="0">
                 <a:solidFill>
                   <a:schemeClr val="tx2"/>
                 </a:solidFill>
@@ -7297,7 +7297,7 @@
               </a:rPr>
               <a:t>Conflitto</a:t>
             </a:r>
-            <a:endParaRPr lang="en-US" sz="1800" dirty="0"/>
+            <a:endParaRPr lang="en-US" sz="1600" dirty="0"/>
           </a:p>
         </p:txBody>
       </p:sp>
@@ -7309,8 +7309,8 @@
         </p:nvSpPr>
         <p:spPr>
           <a:xfrm>
-            <a:off x="5532120" y="1737360"/>
-            <a:ext cx="3017520" cy="502920"/>
+            <a:off x="5532120" y="1508760"/>
+            <a:ext cx="3017520" cy="384048"/>
           </a:xfrm>
           <a:prstGeom prst="rect">
             <a:avLst/>
@@ -7326,7 +7326,7 @@
               <a:buNone/>
             </a:pPr>
             <a:r>
-              <a:rPr lang="en-US" sz="1400" dirty="0">
+              <a:rPr lang="en-US" sz="1200" dirty="0">
                 <a:solidFill>
                   <a:schemeClr val="tx1"/>
                 </a:solidFill>
@@ -7336,7 +7336,7 @@
               </a:rPr>
               <a:t>Fascia sovrapposta: messaggio e 409</a:t>
             </a:r>
-            <a:endParaRPr lang="en-US" sz="1400" dirty="0"/>
+            <a:endParaRPr lang="en-US" sz="1200" dirty="0"/>
           </a:p>
         </p:txBody>
       </p:sp>
@@ -7348,8 +7348,8 @@
         </p:nvSpPr>
         <p:spPr>
           <a:xfrm>
-            <a:off x="457200" y="2423160"/>
-            <a:ext cx="4023360" cy="1005840"/>
+            <a:off x="457200" y="2029968"/>
+            <a:ext cx="4023360" cy="777240"/>
           </a:xfrm>
           <a:prstGeom prst="rect">
             <a:avLst/>
@@ -7373,8 +7373,8 @@
         </p:nvSpPr>
         <p:spPr>
           <a:xfrm>
-            <a:off x="640080" y="2606040"/>
-            <a:ext cx="548640" cy="640080"/>
+            <a:off x="640080" y="2121408"/>
+            <a:ext cx="548640" cy="594360"/>
           </a:xfrm>
           <a:prstGeom prst="rect">
             <a:avLst/>
@@ -7390,7 +7390,7 @@
               <a:buNone/>
             </a:pPr>
             <a:r>
-              <a:rPr lang="en-US" sz="3600" b="1" dirty="0">
+              <a:rPr lang="en-US" sz="3000" b="1" dirty="0">
                 <a:solidFill>
                   <a:schemeClr val="accent2"/>
                 </a:solidFill>
@@ -7400,7 +7400,7 @@
               </a:rPr>
               <a:t>3</a:t>
             </a:r>
-            <a:endParaRPr lang="en-US" sz="3600" dirty="0"/>
+            <a:endParaRPr lang="en-US" sz="3000" dirty="0"/>
           </a:p>
         </p:txBody>
       </p:sp>
@@ -7412,8 +7412,8 @@
         </p:nvSpPr>
         <p:spPr>
           <a:xfrm>
-            <a:off x="1325880" y="2532888"/>
-            <a:ext cx="3017520" cy="329184"/>
+            <a:off x="1325880" y="2093976"/>
+            <a:ext cx="3017520" cy="292608"/>
           </a:xfrm>
           <a:prstGeom prst="rect">
             <a:avLst/>
@@ -7429,7 +7429,7 @@
               <a:buNone/>
             </a:pPr>
             <a:r>
-              <a:rPr lang="en-US" sz="1800" b="1" dirty="0">
+              <a:rPr lang="en-US" sz="1600" b="1" dirty="0">
                 <a:solidFill>
                   <a:schemeClr val="tx2"/>
                 </a:solidFill>
@@ -7439,7 +7439,7 @@
               </a:rPr>
               <a:t>Adiacenti</a:t>
             </a:r>
-            <a:endParaRPr lang="en-US" sz="1800" dirty="0"/>
+            <a:endParaRPr lang="en-US" sz="1600" dirty="0"/>
           </a:p>
         </p:txBody>
       </p:sp>
@@ -7451,8 +7451,8 @@
         </p:nvSpPr>
         <p:spPr>
           <a:xfrm>
-            <a:off x="1325880" y="2880360"/>
-            <a:ext cx="3017520" cy="502920"/>
+            <a:off x="1325880" y="2395728"/>
+            <a:ext cx="3017520" cy="384048"/>
           </a:xfrm>
           <a:prstGeom prst="rect">
             <a:avLst/>
@@ -7468,7 +7468,7 @@
               <a:buNone/>
             </a:pPr>
             <a:r>
-              <a:rPr lang="en-US" sz="1400" dirty="0">
+              <a:rPr lang="en-US" sz="1200" dirty="0">
                 <a:solidFill>
                   <a:schemeClr val="tx1"/>
                 </a:solidFill>
@@ -7478,7 +7478,7 @@
               </a:rPr>
               <a:t>Una finisce quando inizia l'altra: entrambe accettate</a:t>
             </a:r>
-            <a:endParaRPr lang="en-US" sz="1400" dirty="0"/>
+            <a:endParaRPr lang="en-US" sz="1200" dirty="0"/>
           </a:p>
         </p:txBody>
       </p:sp>
@@ -7490,8 +7490,8 @@
         </p:nvSpPr>
         <p:spPr>
           <a:xfrm>
-            <a:off x="4663440" y="2423160"/>
-            <a:ext cx="4023360" cy="1005840"/>
+            <a:off x="4663440" y="2029968"/>
+            <a:ext cx="4023360" cy="777240"/>
           </a:xfrm>
           <a:prstGeom prst="rect">
             <a:avLst/>
@@ -7515,8 +7515,8 @@
         </p:nvSpPr>
         <p:spPr>
           <a:xfrm>
-            <a:off x="4846320" y="2606040"/>
-            <a:ext cx="548640" cy="640080"/>
+            <a:off x="4846320" y="2121408"/>
+            <a:ext cx="548640" cy="594360"/>
           </a:xfrm>
           <a:prstGeom prst="rect">
             <a:avLst/>
@@ -7532,7 +7532,7 @@
               <a:buNone/>
             </a:pPr>
             <a:r>
-              <a:rPr lang="en-US" sz="3600" b="1" dirty="0">
+              <a:rPr lang="en-US" sz="3000" b="1" dirty="0">
                 <a:solidFill>
                   <a:schemeClr val="accent2"/>
                 </a:solidFill>
@@ -7542,7 +7542,7 @@
               </a:rPr>
               <a:t>4</a:t>
             </a:r>
-            <a:endParaRPr lang="en-US" sz="3600" dirty="0"/>
+            <a:endParaRPr lang="en-US" sz="3000" dirty="0"/>
           </a:p>
         </p:txBody>
       </p:sp>
@@ -7554,8 +7554,8 @@
         </p:nvSpPr>
         <p:spPr>
           <a:xfrm>
-            <a:off x="5532120" y="2532888"/>
-            <a:ext cx="3017520" cy="329184"/>
+            <a:off x="5532120" y="2093976"/>
+            <a:ext cx="3017520" cy="292608"/>
           </a:xfrm>
           <a:prstGeom prst="rect">
             <a:avLst/>
@@ -7571,7 +7571,7 @@
               <a:buNone/>
             </a:pPr>
             <a:r>
-              <a:rPr lang="en-US" sz="1800" b="1" dirty="0">
+              <a:rPr lang="en-US" sz="1600" b="1" dirty="0">
                 <a:solidFill>
                   <a:schemeClr val="tx2"/>
                 </a:solidFill>
@@ -7581,7 +7581,7 @@
               </a:rPr>
               <a:t>Annullare</a:t>
             </a:r>
-            <a:endParaRPr lang="en-US" sz="1800" dirty="0"/>
+            <a:endParaRPr lang="en-US" sz="1600" dirty="0"/>
           </a:p>
         </p:txBody>
       </p:sp>
@@ -7593,8 +7593,8 @@
         </p:nvSpPr>
         <p:spPr>
           <a:xfrm>
-            <a:off x="5532120" y="2880360"/>
-            <a:ext cx="3017520" cy="502920"/>
+            <a:off x="5532120" y="2395728"/>
+            <a:ext cx="3017520" cy="384048"/>
           </a:xfrm>
           <a:prstGeom prst="rect">
             <a:avLst/>
@@ -7610,7 +7610,7 @@
               <a:buNone/>
             </a:pPr>
             <a:r>
-              <a:rPr lang="en-US" sz="1400" dirty="0">
+              <a:rPr lang="en-US" sz="1200" dirty="0">
                 <a:solidFill>
                   <a:schemeClr val="tx1"/>
                 </a:solidFill>
@@ -7618,9 +7618,9 @@
                 <a:ea typeface="Calibri" pitchFamily="34" charset="-122"/>
                 <a:cs typeface="Calibri" pitchFamily="34" charset="-120"/>
               </a:rPr>
-              <a:t>La fascia torna libera per tutti</a:t>
-            </a:r>
-            <a:endParaRPr lang="en-US" sz="1400" dirty="0"/>
+              <a:t>Solo l'organizzatore; la fascia torna libera per tutti</a:t>
+            </a:r>
+            <a:endParaRPr lang="en-US" sz="1200" dirty="0"/>
           </a:p>
         </p:txBody>
       </p:sp>
@@ -7632,8 +7632,8 @@
         </p:nvSpPr>
         <p:spPr>
           <a:xfrm>
-            <a:off x="457200" y="3566160"/>
-            <a:ext cx="4023360" cy="1005840"/>
+            <a:off x="457200" y="2916936"/>
+            <a:ext cx="4023360" cy="777240"/>
           </a:xfrm>
           <a:prstGeom prst="rect">
             <a:avLst/>
@@ -7657,8 +7657,8 @@
         </p:nvSpPr>
         <p:spPr>
           <a:xfrm>
-            <a:off x="640080" y="3749040"/>
-            <a:ext cx="548640" cy="640080"/>
+            <a:off x="640080" y="3008376"/>
+            <a:ext cx="548640" cy="594360"/>
           </a:xfrm>
           <a:prstGeom prst="rect">
             <a:avLst/>
@@ -7674,7 +7674,7 @@
               <a:buNone/>
             </a:pPr>
             <a:r>
-              <a:rPr lang="en-US" sz="3600" b="1" dirty="0">
+              <a:rPr lang="en-US" sz="3000" b="1" dirty="0">
                 <a:solidFill>
                   <a:schemeClr val="accent2"/>
                 </a:solidFill>
@@ -7684,7 +7684,7 @@
               </a:rPr>
               <a:t>5</a:t>
             </a:r>
-            <a:endParaRPr lang="en-US" sz="3600" dirty="0"/>
+            <a:endParaRPr lang="en-US" sz="3000" dirty="0"/>
           </a:p>
         </p:txBody>
       </p:sp>
@@ -7696,8 +7696,8 @@
         </p:nvSpPr>
         <p:spPr>
           <a:xfrm>
-            <a:off x="1325880" y="3675888"/>
-            <a:ext cx="3017520" cy="329184"/>
+            <a:off x="1325880" y="2980944"/>
+            <a:ext cx="3017520" cy="292608"/>
           </a:xfrm>
           <a:prstGeom prst="rect">
             <a:avLst/>
@@ -7713,7 +7713,7 @@
               <a:buNone/>
             </a:pPr>
             <a:r>
-              <a:rPr lang="en-US" sz="1800" b="1" dirty="0">
+              <a:rPr lang="en-US" sz="1600" b="1" dirty="0">
                 <a:solidFill>
                   <a:schemeClr val="tx2"/>
                 </a:solidFill>
@@ -7723,7 +7723,7 @@
               </a:rPr>
               <a:t>Aula piena</a:t>
             </a:r>
-            <a:endParaRPr lang="en-US" sz="1800" dirty="0"/>
+            <a:endParaRPr lang="en-US" sz="1600" dirty="0"/>
           </a:p>
         </p:txBody>
       </p:sp>
@@ -7735,8 +7735,8 @@
         </p:nvSpPr>
         <p:spPr>
           <a:xfrm>
-            <a:off x="1325880" y="4023360"/>
-            <a:ext cx="3017520" cy="502920"/>
+            <a:off x="1325880" y="3282696"/>
+            <a:ext cx="3017520" cy="384048"/>
           </a:xfrm>
           <a:prstGeom prst="rect">
             <a:avLst/>
@@ -7752,7 +7752,7 @@
               <a:buNone/>
             </a:pPr>
             <a:r>
-              <a:rPr lang="en-US" sz="1400" dirty="0">
+              <a:rPr lang="en-US" sz="1200" dirty="0">
                 <a:solidFill>
                   <a:schemeClr val="tx1"/>
                 </a:solidFill>
@@ -7762,7 +7762,7 @@
               </a:rPr>
               <a:t>Aula 204 da 6 posti: la settima persona viene rifiutata</a:t>
             </a:r>
-            <a:endParaRPr lang="en-US" sz="1400" dirty="0"/>
+            <a:endParaRPr lang="en-US" sz="1200" dirty="0"/>
           </a:p>
         </p:txBody>
       </p:sp>
@@ -7774,8 +7774,8 @@
         </p:nvSpPr>
         <p:spPr>
           <a:xfrm>
-            <a:off x="4663440" y="3566160"/>
-            <a:ext cx="4023360" cy="1005840"/>
+            <a:off x="4663440" y="2916936"/>
+            <a:ext cx="4023360" cy="777240"/>
           </a:xfrm>
           <a:prstGeom prst="rect">
             <a:avLst/>
@@ -7799,8 +7799,8 @@
         </p:nvSpPr>
         <p:spPr>
           <a:xfrm>
-            <a:off x="4846320" y="3749040"/>
-            <a:ext cx="548640" cy="640080"/>
+            <a:off x="4846320" y="3008376"/>
+            <a:ext cx="548640" cy="594360"/>
           </a:xfrm>
           <a:prstGeom prst="rect">
             <a:avLst/>
@@ -7816,7 +7816,7 @@
               <a:buNone/>
             </a:pPr>
             <a:r>
-              <a:rPr lang="en-US" sz="3600" b="1" dirty="0">
+              <a:rPr lang="en-US" sz="3000" b="1" dirty="0">
                 <a:solidFill>
                   <a:schemeClr val="accent2"/>
                 </a:solidFill>
@@ -7826,7 +7826,7 @@
               </a:rPr>
               <a:t>6</a:t>
             </a:r>
-            <a:endParaRPr lang="en-US" sz="3600" dirty="0"/>
+            <a:endParaRPr lang="en-US" sz="3000" dirty="0"/>
           </a:p>
         </p:txBody>
       </p:sp>
@@ -7838,8 +7838,8 @@
         </p:nvSpPr>
         <p:spPr>
           <a:xfrm>
-            <a:off x="5532120" y="3675888"/>
-            <a:ext cx="3017520" cy="329184"/>
+            <a:off x="5532120" y="2980944"/>
+            <a:ext cx="3017520" cy="292608"/>
           </a:xfrm>
           <a:prstGeom prst="rect">
             <a:avLst/>
@@ -7855,7 +7855,7 @@
               <a:buNone/>
             </a:pPr>
             <a:r>
-              <a:rPr lang="en-US" sz="1800" b="1" dirty="0">
+              <a:rPr lang="en-US" sz="1600" b="1" dirty="0">
                 <a:solidFill>
                   <a:schemeClr val="tx2"/>
                 </a:solidFill>
@@ -7865,7 +7865,7 @@
               </a:rPr>
               <a:t>Commento</a:t>
             </a:r>
-            <a:endParaRPr lang="en-US" sz="1800" dirty="0"/>
+            <a:endParaRPr lang="en-US" sz="1600" dirty="0"/>
           </a:p>
         </p:txBody>
       </p:sp>
@@ -7877,8 +7877,8 @@
         </p:nvSpPr>
         <p:spPr>
           <a:xfrm>
-            <a:off x="5532120" y="4023360"/>
-            <a:ext cx="3017520" cy="502920"/>
+            <a:off x="5532120" y="3282696"/>
+            <a:ext cx="3017520" cy="384048"/>
           </a:xfrm>
           <a:prstGeom prst="rect">
             <a:avLst/>
@@ -7894,7 +7894,7 @@
               <a:buNone/>
             </a:pPr>
             <a:r>
-              <a:rPr lang="en-US" sz="1400" dirty="0">
+              <a:rPr lang="en-US" sz="1200" dirty="0">
                 <a:solidFill>
                   <a:schemeClr val="tx1"/>
                 </a:solidFill>
@@ -7904,7 +7904,291 @@
               </a:rPr>
               <a:t>Senza commento finale non si prenota di nuovo</a:t>
             </a:r>
-            <a:endParaRPr lang="en-US" sz="1400" dirty="0"/>
+            <a:endParaRPr lang="en-US" sz="1200" dirty="0"/>
+          </a:p>
+        </p:txBody>
+      </p:sp>
+      <p:sp>
+        <p:nvSpPr>
+          <p:cNvPr id="28" name="card-87"/>
+          <p:cNvSpPr/>
+          <p:nvPr/>
+        </p:nvSpPr>
+        <p:spPr>
+          <a:xfrm>
+            <a:off x="457200" y="3803904"/>
+            <a:ext cx="4023360" cy="777240"/>
+          </a:xfrm>
+          <a:prstGeom prst="rect">
+            <a:avLst/>
+          </a:prstGeom>
+          <a:solidFill>
+            <a:schemeClr val="bg2"/>
+          </a:solidFill>
+          <a:ln w="12700">
+            <a:solidFill>
+              <a:schemeClr val="bg2"/>
+            </a:solidFill>
+            <a:prstDash val="solid"/>
+          </a:ln>
+        </p:spPr>
+      </p:sp>
+      <p:sp>
+        <p:nvSpPr>
+          <p:cNvPr id="29" name="text-88"/>
+          <p:cNvSpPr txBox="1"/>
+          <p:nvPr/>
+        </p:nvSpPr>
+        <p:spPr>
+          <a:xfrm>
+            <a:off x="640080" y="3895344"/>
+            <a:ext cx="548640" cy="594360"/>
+          </a:xfrm>
+          <a:prstGeom prst="rect">
+            <a:avLst/>
+          </a:prstGeom>
+          <a:noFill/>
+          <a:ln/>
+        </p:spPr>
+        <p:txBody>
+          <a:bodyPr wrap="square" lIns="0" tIns="0" rIns="0" bIns="0" rtlCol="0" anchor="ctr"/>
+          <a:lstStyle/>
+          <a:p>
+            <a:pPr indent="0" marL="0">
+              <a:buNone/>
+            </a:pPr>
+            <a:r>
+              <a:rPr lang="en-US" sz="3000" b="1" dirty="0">
+                <a:solidFill>
+                  <a:schemeClr val="accent2"/>
+                </a:solidFill>
+                <a:latin typeface="Cambria" pitchFamily="34" charset="0"/>
+                <a:ea typeface="Cambria" pitchFamily="34" charset="-122"/>
+                <a:cs typeface="Cambria" pitchFamily="34" charset="-120"/>
+              </a:rPr>
+              <a:t>7</a:t>
+            </a:r>
+            <a:endParaRPr lang="en-US" sz="3000" dirty="0"/>
+          </a:p>
+        </p:txBody>
+      </p:sp>
+      <p:sp>
+        <p:nvSpPr>
+          <p:cNvPr id="30" name="text-89"/>
+          <p:cNvSpPr txBox="1"/>
+          <p:nvPr/>
+        </p:nvSpPr>
+        <p:spPr>
+          <a:xfrm>
+            <a:off x="1325880" y="3867912"/>
+            <a:ext cx="3017520" cy="292608"/>
+          </a:xfrm>
+          <a:prstGeom prst="rect">
+            <a:avLst/>
+          </a:prstGeom>
+          <a:noFill/>
+          <a:ln/>
+        </p:spPr>
+        <p:txBody>
+          <a:bodyPr wrap="square" lIns="0" tIns="0" rIns="0" bIns="0" rtlCol="0" anchor="t"/>
+          <a:lstStyle/>
+          <a:p>
+            <a:pPr indent="0" marL="0">
+              <a:buNone/>
+            </a:pPr>
+            <a:r>
+              <a:rPr lang="en-US" sz="1600" b="1" dirty="0">
+                <a:solidFill>
+                  <a:schemeClr val="tx2"/>
+                </a:solidFill>
+                <a:latin typeface="Cambria" pitchFamily="34" charset="0"/>
+                <a:ea typeface="Cambria" pitchFamily="34" charset="-122"/>
+                <a:cs typeface="Cambria" pitchFamily="34" charset="-120"/>
+              </a:rPr>
+              <a:t>Gruppo</a:t>
+            </a:r>
+            <a:endParaRPr lang="en-US" sz="1600" dirty="0"/>
+          </a:p>
+        </p:txBody>
+      </p:sp>
+      <p:sp>
+        <p:nvSpPr>
+          <p:cNvPr id="31" name="text-90"/>
+          <p:cNvSpPr txBox="1"/>
+          <p:nvPr/>
+        </p:nvSpPr>
+        <p:spPr>
+          <a:xfrm>
+            <a:off x="1325880" y="4169664"/>
+            <a:ext cx="3017520" cy="384048"/>
+          </a:xfrm>
+          <a:prstGeom prst="rect">
+            <a:avLst/>
+          </a:prstGeom>
+          <a:noFill/>
+          <a:ln/>
+        </p:spPr>
+        <p:txBody>
+          <a:bodyPr wrap="square" lIns="0" tIns="0" rIns="0" bIns="0" rtlCol="0" anchor="t"/>
+          <a:lstStyle/>
+          <a:p>
+            <a:pPr indent="0" marL="0">
+              <a:buNone/>
+            </a:pPr>
+            <a:r>
+              <a:rPr lang="en-US" sz="1200" dirty="0">
+                <a:solidFill>
+                  <a:schemeClr val="tx1"/>
+                </a:solidFill>
+                <a:latin typeface="Calibri" pitchFamily="34" charset="0"/>
+                <a:ea typeface="Calibri" pitchFamily="34" charset="-122"/>
+                <a:cs typeface="Calibri" pitchFamily="34" charset="-120"/>
+              </a:rPr>
+              <a:t>Inviti per email; l'invitato conferma, un altro utente no</a:t>
+            </a:r>
+            <a:endParaRPr lang="en-US" sz="1200" dirty="0"/>
+          </a:p>
+        </p:txBody>
+      </p:sp>
+      <p:sp>
+        <p:nvSpPr>
+          <p:cNvPr id="32" name="card-91"/>
+          <p:cNvSpPr/>
+          <p:nvPr/>
+        </p:nvSpPr>
+        <p:spPr>
+          <a:xfrm>
+            <a:off x="4663440" y="3803904"/>
+            <a:ext cx="4023360" cy="777240"/>
+          </a:xfrm>
+          <a:prstGeom prst="rect">
+            <a:avLst/>
+          </a:prstGeom>
+          <a:solidFill>
+            <a:schemeClr val="bg2"/>
+          </a:solidFill>
+          <a:ln w="12700">
+            <a:solidFill>
+              <a:schemeClr val="bg2"/>
+            </a:solidFill>
+            <a:prstDash val="solid"/>
+          </a:ln>
+        </p:spPr>
+      </p:sp>
+      <p:sp>
+        <p:nvSpPr>
+          <p:cNvPr id="33" name="text-92"/>
+          <p:cNvSpPr txBox="1"/>
+          <p:nvPr/>
+        </p:nvSpPr>
+        <p:spPr>
+          <a:xfrm>
+            <a:off x="4846320" y="3895344"/>
+            <a:ext cx="548640" cy="594360"/>
+          </a:xfrm>
+          <a:prstGeom prst="rect">
+            <a:avLst/>
+          </a:prstGeom>
+          <a:noFill/>
+          <a:ln/>
+        </p:spPr>
+        <p:txBody>
+          <a:bodyPr wrap="square" lIns="0" tIns="0" rIns="0" bIns="0" rtlCol="0" anchor="ctr"/>
+          <a:lstStyle/>
+          <a:p>
+            <a:pPr indent="0" marL="0">
+              <a:buNone/>
+            </a:pPr>
+            <a:r>
+              <a:rPr lang="en-US" sz="3000" b="1" dirty="0">
+                <a:solidFill>
+                  <a:schemeClr val="accent2"/>
+                </a:solidFill>
+                <a:latin typeface="Cambria" pitchFamily="34" charset="0"/>
+                <a:ea typeface="Cambria" pitchFamily="34" charset="-122"/>
+                <a:cs typeface="Cambria" pitchFamily="34" charset="-120"/>
+              </a:rPr>
+              <a:t>8</a:t>
+            </a:r>
+            <a:endParaRPr lang="en-US" sz="3000" dirty="0"/>
+          </a:p>
+        </p:txBody>
+      </p:sp>
+      <p:sp>
+        <p:nvSpPr>
+          <p:cNvPr id="34" name="text-93"/>
+          <p:cNvSpPr txBox="1"/>
+          <p:nvPr/>
+        </p:nvSpPr>
+        <p:spPr>
+          <a:xfrm>
+            <a:off x="5532120" y="3867912"/>
+            <a:ext cx="3017520" cy="292608"/>
+          </a:xfrm>
+          <a:prstGeom prst="rect">
+            <a:avLst/>
+          </a:prstGeom>
+          <a:noFill/>
+          <a:ln/>
+        </p:spPr>
+        <p:txBody>
+          <a:bodyPr wrap="square" lIns="0" tIns="0" rIns="0" bIns="0" rtlCol="0" anchor="t"/>
+          <a:lstStyle/>
+          <a:p>
+            <a:pPr indent="0" marL="0">
+              <a:buNone/>
+            </a:pPr>
+            <a:r>
+              <a:rPr lang="en-US" sz="1600" b="1" dirty="0">
+                <a:solidFill>
+                  <a:schemeClr val="tx2"/>
+                </a:solidFill>
+                <a:latin typeface="Cambria" pitchFamily="34" charset="0"/>
+                <a:ea typeface="Cambria" pitchFamily="34" charset="-122"/>
+                <a:cs typeface="Cambria" pitchFamily="34" charset="-120"/>
+              </a:rPr>
+              <a:t>Admin</a:t>
+            </a:r>
+            <a:endParaRPr lang="en-US" sz="1600" dirty="0"/>
+          </a:p>
+        </p:txBody>
+      </p:sp>
+      <p:sp>
+        <p:nvSpPr>
+          <p:cNvPr id="35" name="text-94"/>
+          <p:cNvSpPr txBox="1"/>
+          <p:nvPr/>
+        </p:nvSpPr>
+        <p:spPr>
+          <a:xfrm>
+            <a:off x="5532120" y="4169664"/>
+            <a:ext cx="3017520" cy="384048"/>
+          </a:xfrm>
+          <a:prstGeom prst="rect">
+            <a:avLst/>
+          </a:prstGeom>
+          <a:noFill/>
+          <a:ln/>
+        </p:spPr>
+        <p:txBody>
+          <a:bodyPr wrap="square" lIns="0" tIns="0" rIns="0" bIns="0" rtlCol="0" anchor="t"/>
+          <a:lstStyle/>
+          <a:p>
+            <a:pPr indent="0" marL="0">
+              <a:buNone/>
+            </a:pPr>
+            <a:r>
+              <a:rPr lang="en-US" sz="1200" dirty="0">
+                <a:solidFill>
+                  <a:schemeClr val="tx1"/>
+                </a:solidFill>
+                <a:latin typeface="Calibri" pitchFamily="34" charset="0"/>
+                <a:ea typeface="Calibri" pitchFamily="34" charset="-122"/>
+                <a:cs typeface="Calibri" pitchFamily="34" charset="-120"/>
+              </a:rPr>
+              <a:t>La dashboard solo per l'admin; Spaces fermo: 503</a:t>
+            </a:r>
+            <a:endParaRPr lang="en-US" sz="1200" dirty="0"/>
           </a:p>
         </p:txBody>
       </p:sp>
@@ -8021,7 +8305,7 @@
       </p:sp>
       <p:graphicFrame>
         <p:nvGraphicFramePr>
-          <p:cNvPr id="9" name="table-87"/>
+          <p:cNvPr id="9" name="table-95"/>
           <p:cNvGraphicFramePr>
             <a:graphicFrameLocks noGrp="1"/>
           </p:cNvGraphicFramePr>
@@ -8034,7 +8318,7 @@
           </p:nvPr>
         </p:nvGraphicFramePr>
         <p:xfrm>
-          <a:off x="457200" y="1234440"/>
+          <a:off x="457200" y="1188720"/>
           <a:ext cx="8229600" cy="914400"/>
         </p:xfrm>
         <a:graphic>
@@ -8043,10 +8327,10 @@
               <a:tblPr/>
               <a:tblGrid>
                 <a:gridCol w="2194560"/>
-                <a:gridCol w="4206240"/>
-                <a:gridCol w="1828800"/>
+                <a:gridCol w="4114800"/>
+                <a:gridCol w="1920240"/>
               </a:tblGrid>
-              <a:tr h="548640">
+              <a:tr h="475488">
                 <a:tc>
                   <a:txBody>
                     <a:bodyPr/>
@@ -8056,7 +8340,7 @@
                         <a:buNone/>
                       </a:pPr>
                       <a:r>
-                        <a:rPr lang="en-US" sz="1300" b="1" dirty="0">
+                        <a:rPr lang="en-US" sz="1200" b="1" dirty="0">
                           <a:solidFill>
                             <a:schemeClr val="bg1"/>
                           </a:solidFill>
@@ -8066,14 +8350,14 @@
                         </a:rPr>
                         <a:t>Prova</a:t>
                       </a:r>
-                      <a:endParaRPr lang="en-US" sz="1300" dirty="0">
+                      <a:endParaRPr lang="en-US" sz="1200" dirty="0">
                         <a:latin typeface="Calibri" charset="0"/>
                         <a:ea typeface="Calibri" charset="0"/>
                         <a:cs typeface="Calibri" charset="0"/>
                       </a:endParaRPr>
                     </a:p>
                   </a:txBody>
-                  <a:tcPr marL="91440" marR="91440" marT="45720" marB="45720" anchor="ctr">
+                  <a:tcPr marL="91440" marR="91440" marT="36576" marB="36576" anchor="ctr">
                     <a:lnL w="9525" cap="flat" cmpd="sng" algn="ctr">
                       <a:solidFill>
                         <a:srgbClr val="D5DEDC"/>
@@ -8124,7 +8408,7 @@
                         <a:buNone/>
                       </a:pPr>
                       <a:r>
-                        <a:rPr lang="en-US" sz="1300" b="1" dirty="0">
+                        <a:rPr lang="en-US" sz="1200" b="1" dirty="0">
                           <a:solidFill>
                             <a:schemeClr val="bg1"/>
                           </a:solidFill>
@@ -8134,14 +8418,14 @@
                         </a:rPr>
                         <a:t>Cosa dimostra</a:t>
                       </a:r>
-                      <a:endParaRPr lang="en-US" sz="1300" dirty="0">
+                      <a:endParaRPr lang="en-US" sz="1200" dirty="0">
                         <a:latin typeface="Calibri" charset="0"/>
                         <a:ea typeface="Calibri" charset="0"/>
                         <a:cs typeface="Calibri" charset="0"/>
                       </a:endParaRPr>
                     </a:p>
                   </a:txBody>
-                  <a:tcPr marL="91440" marR="91440" marT="45720" marB="45720" anchor="ctr">
+                  <a:tcPr marL="91440" marR="91440" marT="36576" marB="36576" anchor="ctr">
                     <a:lnL w="9525" cap="flat" cmpd="sng" algn="ctr">
                       <a:solidFill>
                         <a:srgbClr val="D5DEDC"/>
@@ -8192,7 +8476,7 @@
                         <a:buNone/>
                       </a:pPr>
                       <a:r>
-                        <a:rPr lang="en-US" sz="1300" b="1" dirty="0">
+                        <a:rPr lang="en-US" sz="1200" b="1" dirty="0">
                           <a:solidFill>
                             <a:schemeClr val="bg1"/>
                           </a:solidFill>
@@ -8202,14 +8486,14 @@
                         </a:rPr>
                         <a:t>Esito</a:t>
                       </a:r>
-                      <a:endParaRPr lang="en-US" sz="1300" dirty="0">
+                      <a:endParaRPr lang="en-US" sz="1200" dirty="0">
                         <a:latin typeface="Calibri" charset="0"/>
                         <a:ea typeface="Calibri" charset="0"/>
                         <a:cs typeface="Calibri" charset="0"/>
                       </a:endParaRPr>
                     </a:p>
                   </a:txBody>
-                  <a:tcPr marL="91440" marR="91440" marT="45720" marB="45720" anchor="ctr">
+                  <a:tcPr marL="91440" marR="91440" marT="36576" marB="36576" anchor="ctr">
                     <a:lnL w="9525" cap="flat" cmpd="sng" algn="ctr">
                       <a:solidFill>
                         <a:srgbClr val="D5DEDC"/>
@@ -8252,7 +8536,7 @@
                   </a:tcPr>
                 </a:tc>
               </a:tr>
-              <a:tr h="548640">
+              <a:tr h="475488">
                 <a:tc>
                   <a:txBody>
                     <a:bodyPr/>
@@ -8262,7 +8546,7 @@
                         <a:buNone/>
                       </a:pPr>
                       <a:r>
-                        <a:rPr lang="en-US" sz="1300" b="1" dirty="0">
+                        <a:rPr lang="en-US" sz="1200" b="1" dirty="0">
                           <a:solidFill>
                             <a:schemeClr val="tx2"/>
                           </a:solidFill>
@@ -8272,14 +8556,14 @@
                         </a:rPr>
                         <a:t>Concorrenza sul database</a:t>
                       </a:r>
-                      <a:endParaRPr lang="en-US" sz="1300" dirty="0">
+                      <a:endParaRPr lang="en-US" sz="1200" dirty="0">
                         <a:latin typeface="Calibri" charset="0"/>
                         <a:ea typeface="Calibri" charset="0"/>
                         <a:cs typeface="Calibri" charset="0"/>
                       </a:endParaRPr>
                     </a:p>
                   </a:txBody>
-                  <a:tcPr marL="91440" marR="91440" marT="45720" marB="45720" anchor="ctr">
+                  <a:tcPr marL="91440" marR="91440" marT="36576" marB="36576" anchor="ctr">
                     <a:lnL w="9525" cap="flat" cmpd="sng" algn="ctr">
                       <a:solidFill>
                         <a:srgbClr val="D5DEDC"/>
@@ -8327,7 +8611,7 @@
                         <a:buNone/>
                       </a:pPr>
                       <a:r>
-                        <a:rPr lang="en-US" sz="1300" dirty="0">
+                        <a:rPr lang="en-US" sz="1200" dirty="0">
                           <a:solidFill>
                             <a:schemeClr val="tx1"/>
                           </a:solidFill>
@@ -8337,14 +8621,14 @@
                         </a:rPr>
                         <a:t>16 richieste simultanee: una sola accettata sull'aula dedicata</a:t>
                       </a:r>
-                      <a:endParaRPr lang="en-US" sz="1300" dirty="0">
+                      <a:endParaRPr lang="en-US" sz="1200" dirty="0">
                         <a:latin typeface="Calibri" charset="0"/>
                         <a:ea typeface="Calibri" charset="0"/>
                         <a:cs typeface="Calibri" charset="0"/>
                       </a:endParaRPr>
                     </a:p>
                   </a:txBody>
-                  <a:tcPr marL="91440" marR="91440" marT="45720" marB="45720" anchor="ctr">
+                  <a:tcPr marL="91440" marR="91440" marT="36576" marB="36576" anchor="ctr">
                     <a:lnL w="9525" cap="flat" cmpd="sng" algn="ctr">
                       <a:solidFill>
                         <a:srgbClr val="D5DEDC"/>
@@ -8392,7 +8676,7 @@
                         <a:buNone/>
                       </a:pPr>
                       <a:r>
-                        <a:rPr lang="en-US" sz="1300" b="1" dirty="0">
+                        <a:rPr lang="en-US" sz="1200" b="1" dirty="0">
                           <a:solidFill>
                             <a:schemeClr val="accent5"/>
                           </a:solidFill>
@@ -8402,14 +8686,14 @@
                         </a:rPr>
                         <a:t>Superata</a:t>
                       </a:r>
-                      <a:endParaRPr lang="en-US" sz="1300" dirty="0">
+                      <a:endParaRPr lang="en-US" sz="1200" dirty="0">
                         <a:latin typeface="Calibri" charset="0"/>
                         <a:ea typeface="Calibri" charset="0"/>
                         <a:cs typeface="Calibri" charset="0"/>
                       </a:endParaRPr>
                     </a:p>
                   </a:txBody>
-                  <a:tcPr marL="91440" marR="91440" marT="45720" marB="45720" anchor="ctr">
+                  <a:tcPr marL="91440" marR="91440" marT="36576" marB="36576" anchor="ctr">
                     <a:lnL w="9525" cap="flat" cmpd="sng" algn="ctr">
                       <a:solidFill>
                         <a:srgbClr val="D5DEDC"/>
@@ -8449,7 +8733,7 @@
                   </a:tcPr>
                 </a:tc>
               </a:tr>
-              <a:tr h="548640">
+              <a:tr h="475488">
                 <a:tc>
                   <a:txBody>
                     <a:bodyPr/>
@@ -8459,7 +8743,7 @@
                         <a:buNone/>
                       </a:pPr>
                       <a:r>
-                        <a:rPr lang="en-US" sz="1300" b="1" dirty="0">
+                        <a:rPr lang="en-US" sz="1200" b="1" dirty="0">
                           <a:solidFill>
                             <a:schemeClr val="tx2"/>
                           </a:solidFill>
@@ -8469,14 +8753,14 @@
                         </a:rPr>
                         <a:t>Concorrenza via HTTP, aula mista</a:t>
                       </a:r>
-                      <a:endParaRPr lang="en-US" sz="1300" dirty="0">
+                      <a:endParaRPr lang="en-US" sz="1200" dirty="0">
                         <a:latin typeface="Calibri" charset="0"/>
                         <a:ea typeface="Calibri" charset="0"/>
                         <a:cs typeface="Calibri" charset="0"/>
                       </a:endParaRPr>
                     </a:p>
                   </a:txBody>
-                  <a:tcPr marL="91440" marR="91440" marT="45720" marB="45720" anchor="ctr">
+                  <a:tcPr marL="91440" marR="91440" marT="36576" marB="36576" anchor="ctr">
                     <a:lnL w="9525" cap="flat" cmpd="sng" algn="ctr">
                       <a:solidFill>
                         <a:srgbClr val="D5DEDC"/>
@@ -8524,7 +8808,7 @@
                         <a:buNone/>
                       </a:pPr>
                       <a:r>
-                        <a:rPr lang="en-US" sz="1300" dirty="0">
+                        <a:rPr lang="en-US" sz="1200" dirty="0">
                           <a:solidFill>
                             <a:schemeClr val="tx1"/>
                           </a:solidFill>
@@ -8534,14 +8818,14 @@
                         </a:rPr>
                         <a:t>30 richieste su 5 posti: 5 accettate</a:t>
                       </a:r>
-                      <a:endParaRPr lang="en-US" sz="1300" dirty="0">
+                      <a:endParaRPr lang="en-US" sz="1200" dirty="0">
                         <a:latin typeface="Calibri" charset="0"/>
                         <a:ea typeface="Calibri" charset="0"/>
                         <a:cs typeface="Calibri" charset="0"/>
                       </a:endParaRPr>
                     </a:p>
                   </a:txBody>
-                  <a:tcPr marL="91440" marR="91440" marT="45720" marB="45720" anchor="ctr">
+                  <a:tcPr marL="91440" marR="91440" marT="36576" marB="36576" anchor="ctr">
                     <a:lnL w="9525" cap="flat" cmpd="sng" algn="ctr">
                       <a:solidFill>
                         <a:srgbClr val="D5DEDC"/>
@@ -8589,7 +8873,7 @@
                         <a:buNone/>
                       </a:pPr>
                       <a:r>
-                        <a:rPr lang="en-US" sz="1300" b="1" dirty="0">
+                        <a:rPr lang="en-US" sz="1200" b="1" dirty="0">
                           <a:solidFill>
                             <a:schemeClr val="accent2"/>
                           </a:solidFill>
@@ -8597,16 +8881,16 @@
                           <a:ea typeface="Calibri" pitchFamily="34" charset="-122"/>
                           <a:cs typeface="Calibri" pitchFamily="34" charset="-120"/>
                         </a:rPr>
-                        <a:t>Locale sì, in CI un fallimento</a:t>
+                        <a:t>Superata; un fallimento in CI, non riprodotto</a:t>
                       </a:r>
-                      <a:endParaRPr lang="en-US" sz="1300" dirty="0">
+                      <a:endParaRPr lang="en-US" sz="1200" dirty="0">
                         <a:latin typeface="Calibri" charset="0"/>
                         <a:ea typeface="Calibri" charset="0"/>
                         <a:cs typeface="Calibri" charset="0"/>
                       </a:endParaRPr>
                     </a:p>
                   </a:txBody>
-                  <a:tcPr marL="91440" marR="91440" marT="45720" marB="45720" anchor="ctr">
+                  <a:tcPr marL="91440" marR="91440" marT="36576" marB="36576" anchor="ctr">
                     <a:lnL w="9525" cap="flat" cmpd="sng" algn="ctr">
                       <a:solidFill>
                         <a:srgbClr val="D5DEDC"/>
@@ -8646,7 +8930,7 @@
                   </a:tcPr>
                 </a:tc>
               </a:tr>
-              <a:tr h="548640">
+              <a:tr h="475488">
                 <a:tc>
                   <a:txBody>
                     <a:bodyPr/>
@@ -8656,7 +8940,7 @@
                         <a:buNone/>
                       </a:pPr>
                       <a:r>
-                        <a:rPr lang="en-US" sz="1300" b="1" dirty="0">
+                        <a:rPr lang="en-US" sz="1200" b="1" dirty="0">
                           <a:solidFill>
                             <a:schemeClr val="tx2"/>
                           </a:solidFill>
@@ -8666,14 +8950,14 @@
                         </a:rPr>
                         <a:t>Vincoli su spazi e persone</a:t>
                       </a:r>
-                      <a:endParaRPr lang="en-US" sz="1300" dirty="0">
+                      <a:endParaRPr lang="en-US" sz="1200" dirty="0">
                         <a:latin typeface="Calibri" charset="0"/>
                         <a:ea typeface="Calibri" charset="0"/>
                         <a:cs typeface="Calibri" charset="0"/>
                       </a:endParaRPr>
                     </a:p>
                   </a:txBody>
-                  <a:tcPr marL="91440" marR="91440" marT="45720" marB="45720" anchor="ctr">
+                  <a:tcPr marL="91440" marR="91440" marT="36576" marB="36576" anchor="ctr">
                     <a:lnL w="9525" cap="flat" cmpd="sng" algn="ctr">
                       <a:solidFill>
                         <a:srgbClr val="D5DEDC"/>
@@ -8721,7 +9005,7 @@
                         <a:buNone/>
                       </a:pPr>
                       <a:r>
-                        <a:rPr lang="en-US" sz="1300" dirty="0">
+                        <a:rPr lang="en-US" sz="1200" dirty="0">
                           <a:solidFill>
                             <a:schemeClr val="tx1"/>
                           </a:solidFill>
@@ -8731,14 +9015,14 @@
                         </a:rPr>
                         <a:t>Il database rifiuta le sovrapposizioni, accetta le adiacenti</a:t>
                       </a:r>
-                      <a:endParaRPr lang="en-US" sz="1300" dirty="0">
+                      <a:endParaRPr lang="en-US" sz="1200" dirty="0">
                         <a:latin typeface="Calibri" charset="0"/>
                         <a:ea typeface="Calibri" charset="0"/>
                         <a:cs typeface="Calibri" charset="0"/>
                       </a:endParaRPr>
                     </a:p>
                   </a:txBody>
-                  <a:tcPr marL="91440" marR="91440" marT="45720" marB="45720" anchor="ctr">
+                  <a:tcPr marL="91440" marR="91440" marT="36576" marB="36576" anchor="ctr">
                     <a:lnL w="9525" cap="flat" cmpd="sng" algn="ctr">
                       <a:solidFill>
                         <a:srgbClr val="D5DEDC"/>
@@ -8786,7 +9070,7 @@
                         <a:buNone/>
                       </a:pPr>
                       <a:r>
-                        <a:rPr lang="en-US" sz="1300" b="1" dirty="0">
+                        <a:rPr lang="en-US" sz="1200" b="1" dirty="0">
                           <a:solidFill>
                             <a:schemeClr val="accent5"/>
                           </a:solidFill>
@@ -8796,14 +9080,14 @@
                         </a:rPr>
                         <a:t>Superata</a:t>
                       </a:r>
-                      <a:endParaRPr lang="en-US" sz="1300" dirty="0">
+                      <a:endParaRPr lang="en-US" sz="1200" dirty="0">
                         <a:latin typeface="Calibri" charset="0"/>
                         <a:ea typeface="Calibri" charset="0"/>
                         <a:cs typeface="Calibri" charset="0"/>
                       </a:endParaRPr>
                     </a:p>
                   </a:txBody>
-                  <a:tcPr marL="91440" marR="91440" marT="45720" marB="45720" anchor="ctr">
+                  <a:tcPr marL="91440" marR="91440" marT="36576" marB="36576" anchor="ctr">
                     <a:lnL w="9525" cap="flat" cmpd="sng" algn="ctr">
                       <a:solidFill>
                         <a:srgbClr val="D5DEDC"/>
@@ -8843,7 +9127,7 @@
                   </a:tcPr>
                 </a:tc>
               </a:tr>
-              <a:tr h="548640">
+              <a:tr h="475488">
                 <a:tc>
                   <a:txBody>
                     <a:bodyPr/>
@@ -8853,7 +9137,7 @@
                         <a:buNone/>
                       </a:pPr>
                       <a:r>
-                        <a:rPr lang="en-US" sz="1300" b="1" dirty="0">
+                        <a:rPr lang="en-US" sz="1200" b="1" dirty="0">
                           <a:solidFill>
                             <a:schemeClr val="tx2"/>
                           </a:solidFill>
@@ -8863,14 +9147,14 @@
                         </a:rPr>
                         <a:t>Orari e ora legale</a:t>
                       </a:r>
-                      <a:endParaRPr lang="en-US" sz="1300" dirty="0">
+                      <a:endParaRPr lang="en-US" sz="1200" dirty="0">
                         <a:latin typeface="Calibri" charset="0"/>
                         <a:ea typeface="Calibri" charset="0"/>
                         <a:cs typeface="Calibri" charset="0"/>
                       </a:endParaRPr>
                     </a:p>
                   </a:txBody>
-                  <a:tcPr marL="91440" marR="91440" marT="45720" marB="45720" anchor="ctr">
+                  <a:tcPr marL="91440" marR="91440" marT="36576" marB="36576" anchor="ctr">
                     <a:lnL w="9525" cap="flat" cmpd="sng" algn="ctr">
                       <a:solidFill>
                         <a:srgbClr val="D5DEDC"/>
@@ -8918,7 +9202,7 @@
                         <a:buNone/>
                       </a:pPr>
                       <a:r>
-                        <a:rPr lang="en-US" sz="1300" dirty="0">
+                        <a:rPr lang="en-US" sz="1200" dirty="0">
                           <a:solidFill>
                             <a:schemeClr val="tx1"/>
                           </a:solidFill>
@@ -8928,14 +9212,14 @@
                         </a:rPr>
                         <a:t>10:00 a Roma resta 10:00 nei giorni del cambio ora</a:t>
                       </a:r>
-                      <a:endParaRPr lang="en-US" sz="1300" dirty="0">
+                      <a:endParaRPr lang="en-US" sz="1200" dirty="0">
                         <a:latin typeface="Calibri" charset="0"/>
                         <a:ea typeface="Calibri" charset="0"/>
                         <a:cs typeface="Calibri" charset="0"/>
                       </a:endParaRPr>
                     </a:p>
                   </a:txBody>
-                  <a:tcPr marL="91440" marR="91440" marT="45720" marB="45720" anchor="ctr">
+                  <a:tcPr marL="91440" marR="91440" marT="36576" marB="36576" anchor="ctr">
                     <a:lnL w="9525" cap="flat" cmpd="sng" algn="ctr">
                       <a:solidFill>
                         <a:srgbClr val="D5DEDC"/>
@@ -8983,7 +9267,7 @@
                         <a:buNone/>
                       </a:pPr>
                       <a:r>
-                        <a:rPr lang="en-US" sz="1300" b="1" dirty="0">
+                        <a:rPr lang="en-US" sz="1200" b="1" dirty="0">
                           <a:solidFill>
                             <a:schemeClr val="accent5"/>
                           </a:solidFill>
@@ -8993,14 +9277,14 @@
                         </a:rPr>
                         <a:t>Superata</a:t>
                       </a:r>
-                      <a:endParaRPr lang="en-US" sz="1300" dirty="0">
+                      <a:endParaRPr lang="en-US" sz="1200" dirty="0">
                         <a:latin typeface="Calibri" charset="0"/>
                         <a:ea typeface="Calibri" charset="0"/>
                         <a:cs typeface="Calibri" charset="0"/>
                       </a:endParaRPr>
                     </a:p>
                   </a:txBody>
-                  <a:tcPr marL="91440" marR="91440" marT="45720" marB="45720" anchor="ctr">
+                  <a:tcPr marL="91440" marR="91440" marT="36576" marB="36576" anchor="ctr">
                     <a:lnL w="9525" cap="flat" cmpd="sng" algn="ctr">
                       <a:solidFill>
                         <a:srgbClr val="D5DEDC"/>
@@ -9040,7 +9324,7 @@
                   </a:tcPr>
                 </a:tc>
               </a:tr>
-              <a:tr h="548640">
+              <a:tr h="475488">
                 <a:tc>
                   <a:txBody>
                     <a:bodyPr/>
@@ -9050,7 +9334,7 @@
                         <a:buNone/>
                       </a:pPr>
                       <a:r>
-                        <a:rPr lang="en-US" sz="1300" b="1" dirty="0">
+                        <a:rPr lang="en-US" sz="1200" b="1" dirty="0">
                           <a:solidFill>
                             <a:schemeClr val="tx2"/>
                           </a:solidFill>
@@ -9060,14 +9344,14 @@
                         </a:rPr>
                         <a:t>Seed dei dati sintetici</a:t>
                       </a:r>
-                      <a:endParaRPr lang="en-US" sz="1300" dirty="0">
+                      <a:endParaRPr lang="en-US" sz="1200" dirty="0">
                         <a:latin typeface="Calibri" charset="0"/>
                         <a:ea typeface="Calibri" charset="0"/>
                         <a:cs typeface="Calibri" charset="0"/>
                       </a:endParaRPr>
                     </a:p>
                   </a:txBody>
-                  <a:tcPr marL="91440" marR="91440" marT="45720" marB="45720" anchor="ctr">
+                  <a:tcPr marL="91440" marR="91440" marT="36576" marB="36576" anchor="ctr">
                     <a:lnL w="9525" cap="flat" cmpd="sng" algn="ctr">
                       <a:solidFill>
                         <a:srgbClr val="D5DEDC"/>
@@ -9115,7 +9399,7 @@
                         <a:buNone/>
                       </a:pPr>
                       <a:r>
-                        <a:rPr lang="en-US" sz="1300" dirty="0">
+                        <a:rPr lang="en-US" sz="1200" dirty="0">
                           <a:solidFill>
                             <a:schemeClr val="tx1"/>
                           </a:solidFill>
@@ -9125,14 +9409,14 @@
                         </a:rPr>
                         <a:t>Due avvii non duplicano i dati</a:t>
                       </a:r>
-                      <a:endParaRPr lang="en-US" sz="1300" dirty="0">
+                      <a:endParaRPr lang="en-US" sz="1200" dirty="0">
                         <a:latin typeface="Calibri" charset="0"/>
                         <a:ea typeface="Calibri" charset="0"/>
                         <a:cs typeface="Calibri" charset="0"/>
                       </a:endParaRPr>
                     </a:p>
                   </a:txBody>
-                  <a:tcPr marL="91440" marR="91440" marT="45720" marB="45720" anchor="ctr">
+                  <a:tcPr marL="91440" marR="91440" marT="36576" marB="36576" anchor="ctr">
                     <a:lnL w="9525" cap="flat" cmpd="sng" algn="ctr">
                       <a:solidFill>
                         <a:srgbClr val="D5DEDC"/>
@@ -9180,7 +9464,7 @@
                         <a:buNone/>
                       </a:pPr>
                       <a:r>
-                        <a:rPr lang="en-US" sz="1300" b="1" dirty="0">
+                        <a:rPr lang="en-US" sz="1200" b="1" dirty="0">
                           <a:solidFill>
                             <a:schemeClr val="accent5"/>
                           </a:solidFill>
@@ -9190,14 +9474,211 @@
                         </a:rPr>
                         <a:t>Superata</a:t>
                       </a:r>
-                      <a:endParaRPr lang="en-US" sz="1300" dirty="0">
+                      <a:endParaRPr lang="en-US" sz="1200" dirty="0">
                         <a:latin typeface="Calibri" charset="0"/>
                         <a:ea typeface="Calibri" charset="0"/>
                         <a:cs typeface="Calibri" charset="0"/>
                       </a:endParaRPr>
                     </a:p>
                   </a:txBody>
-                  <a:tcPr marL="91440" marR="91440" marT="45720" marB="45720" anchor="ctr">
+                  <a:tcPr marL="91440" marR="91440" marT="36576" marB="36576" anchor="ctr">
+                    <a:lnL w="9525" cap="flat" cmpd="sng" algn="ctr">
+                      <a:solidFill>
+                        <a:srgbClr val="D5DEDC"/>
+                      </a:solidFill>
+                      <a:prstDash val="solid"/>
+                      <a:round/>
+                      <a:headEnd type="none" w="med" len="med"/>
+                      <a:tailEnd type="none" w="med" len="med"/>
+                    </a:lnL>
+                    <a:lnR w="9525" cap="flat" cmpd="sng" algn="ctr">
+                      <a:solidFill>
+                        <a:srgbClr val="D5DEDC"/>
+                      </a:solidFill>
+                      <a:prstDash val="solid"/>
+                      <a:round/>
+                      <a:headEnd type="none" w="med" len="med"/>
+                      <a:tailEnd type="none" w="med" len="med"/>
+                    </a:lnR>
+                    <a:lnT w="9525" cap="flat" cmpd="sng" algn="ctr">
+                      <a:solidFill>
+                        <a:srgbClr val="D5DEDC"/>
+                      </a:solidFill>
+                      <a:prstDash val="solid"/>
+                      <a:round/>
+                      <a:headEnd type="none" w="med" len="med"/>
+                      <a:tailEnd type="none" w="med" len="med"/>
+                    </a:lnT>
+                    <a:lnB w="9525" cap="flat" cmpd="sng" algn="ctr">
+                      <a:solidFill>
+                        <a:srgbClr val="D5DEDC"/>
+                      </a:solidFill>
+                      <a:prstDash val="solid"/>
+                      <a:round/>
+                      <a:headEnd type="none" w="med" len="med"/>
+                      <a:tailEnd type="none" w="med" len="med"/>
+                    </a:lnB>
+                  </a:tcPr>
+                </a:tc>
+              </a:tr>
+              <a:tr h="475488">
+                <a:tc>
+                  <a:txBody>
+                    <a:bodyPr/>
+                    <a:lstStyle/>
+                    <a:p>
+                      <a:pPr indent="0" marL="0">
+                        <a:buNone/>
+                      </a:pPr>
+                      <a:r>
+                        <a:rPr lang="en-US" sz="1200" b="1" dirty="0">
+                          <a:solidFill>
+                            <a:schemeClr val="tx2"/>
+                          </a:solidFill>
+                          <a:latin typeface="Calibri" pitchFamily="34" charset="0"/>
+                          <a:ea typeface="Calibri" pitchFamily="34" charset="-122"/>
+                          <a:cs typeface="Calibri" pitchFamily="34" charset="-120"/>
+                        </a:rPr>
+                        <a:t>Percorso della demo sull'API</a:t>
+                      </a:r>
+                      <a:endParaRPr lang="en-US" sz="1200" dirty="0">
+                        <a:latin typeface="Calibri" charset="0"/>
+                        <a:ea typeface="Calibri" charset="0"/>
+                        <a:cs typeface="Calibri" charset="0"/>
+                      </a:endParaRPr>
+                    </a:p>
+                  </a:txBody>
+                  <a:tcPr marL="91440" marR="91440" marT="36576" marB="36576" anchor="ctr">
+                    <a:lnL w="9525" cap="flat" cmpd="sng" algn="ctr">
+                      <a:solidFill>
+                        <a:srgbClr val="D5DEDC"/>
+                      </a:solidFill>
+                      <a:prstDash val="solid"/>
+                      <a:round/>
+                      <a:headEnd type="none" w="med" len="med"/>
+                      <a:tailEnd type="none" w="med" len="med"/>
+                    </a:lnL>
+                    <a:lnR w="9525" cap="flat" cmpd="sng" algn="ctr">
+                      <a:solidFill>
+                        <a:srgbClr val="D5DEDC"/>
+                      </a:solidFill>
+                      <a:prstDash val="solid"/>
+                      <a:round/>
+                      <a:headEnd type="none" w="med" len="med"/>
+                      <a:tailEnd type="none" w="med" len="med"/>
+                    </a:lnR>
+                    <a:lnT w="9525" cap="flat" cmpd="sng" algn="ctr">
+                      <a:solidFill>
+                        <a:srgbClr val="D5DEDC"/>
+                      </a:solidFill>
+                      <a:prstDash val="solid"/>
+                      <a:round/>
+                      <a:headEnd type="none" w="med" len="med"/>
+                      <a:tailEnd type="none" w="med" len="med"/>
+                    </a:lnT>
+                    <a:lnB w="9525" cap="flat" cmpd="sng" algn="ctr">
+                      <a:solidFill>
+                        <a:srgbClr val="D5DEDC"/>
+                      </a:solidFill>
+                      <a:prstDash val="solid"/>
+                      <a:round/>
+                      <a:headEnd type="none" w="med" len="med"/>
+                      <a:tailEnd type="none" w="med" len="med"/>
+                    </a:lnB>
+                  </a:tcPr>
+                </a:tc>
+                <a:tc>
+                  <a:txBody>
+                    <a:bodyPr/>
+                    <a:lstStyle/>
+                    <a:p>
+                      <a:pPr indent="0" marL="0">
+                        <a:buNone/>
+                      </a:pPr>
+                      <a:r>
+                        <a:rPr lang="en-US" sz="1200" dirty="0">
+                          <a:solidFill>
+                            <a:schemeClr val="tx1"/>
+                          </a:solidFill>
+                          <a:latin typeface="Calibri" pitchFamily="34" charset="0"/>
+                          <a:ea typeface="Calibri" pitchFamily="34" charset="-122"/>
+                          <a:cs typeface="Calibri" pitchFamily="34" charset="-120"/>
+                        </a:rPr>
+                        <a:t>28 chiamate su tre servizi veri: tutte come atteso</a:t>
+                      </a:r>
+                      <a:endParaRPr lang="en-US" sz="1200" dirty="0">
+                        <a:latin typeface="Calibri" charset="0"/>
+                        <a:ea typeface="Calibri" charset="0"/>
+                        <a:cs typeface="Calibri" charset="0"/>
+                      </a:endParaRPr>
+                    </a:p>
+                  </a:txBody>
+                  <a:tcPr marL="91440" marR="91440" marT="36576" marB="36576" anchor="ctr">
+                    <a:lnL w="9525" cap="flat" cmpd="sng" algn="ctr">
+                      <a:solidFill>
+                        <a:srgbClr val="D5DEDC"/>
+                      </a:solidFill>
+                      <a:prstDash val="solid"/>
+                      <a:round/>
+                      <a:headEnd type="none" w="med" len="med"/>
+                      <a:tailEnd type="none" w="med" len="med"/>
+                    </a:lnL>
+                    <a:lnR w="9525" cap="flat" cmpd="sng" algn="ctr">
+                      <a:solidFill>
+                        <a:srgbClr val="D5DEDC"/>
+                      </a:solidFill>
+                      <a:prstDash val="solid"/>
+                      <a:round/>
+                      <a:headEnd type="none" w="med" len="med"/>
+                      <a:tailEnd type="none" w="med" len="med"/>
+                    </a:lnR>
+                    <a:lnT w="9525" cap="flat" cmpd="sng" algn="ctr">
+                      <a:solidFill>
+                        <a:srgbClr val="D5DEDC"/>
+                      </a:solidFill>
+                      <a:prstDash val="solid"/>
+                      <a:round/>
+                      <a:headEnd type="none" w="med" len="med"/>
+                      <a:tailEnd type="none" w="med" len="med"/>
+                    </a:lnT>
+                    <a:lnB w="9525" cap="flat" cmpd="sng" algn="ctr">
+                      <a:solidFill>
+                        <a:srgbClr val="D5DEDC"/>
+                      </a:solidFill>
+                      <a:prstDash val="solid"/>
+                      <a:round/>
+                      <a:headEnd type="none" w="med" len="med"/>
+                      <a:tailEnd type="none" w="med" len="med"/>
+                    </a:lnB>
+                  </a:tcPr>
+                </a:tc>
+                <a:tc>
+                  <a:txBody>
+                    <a:bodyPr/>
+                    <a:lstStyle/>
+                    <a:p>
+                      <a:pPr indent="0" marL="0">
+                        <a:buNone/>
+                      </a:pPr>
+                      <a:r>
+                        <a:rPr lang="en-US" sz="1200" b="1" dirty="0">
+                          <a:solidFill>
+                            <a:schemeClr val="accent5"/>
+                          </a:solidFill>
+                          <a:latin typeface="Calibri" pitchFamily="34" charset="0"/>
+                          <a:ea typeface="Calibri" pitchFamily="34" charset="-122"/>
+                          <a:cs typeface="Calibri" pitchFamily="34" charset="-120"/>
+                        </a:rPr>
+                        <a:t>Superata (28/10)</a:t>
+                      </a:r>
+                      <a:endParaRPr lang="en-US" sz="1200" dirty="0">
+                        <a:latin typeface="Calibri" charset="0"/>
+                        <a:ea typeface="Calibri" charset="0"/>
+                        <a:cs typeface="Calibri" charset="0"/>
+                      </a:endParaRPr>
+                    </a:p>
+                  </a:txBody>
+                  <a:tcPr marL="91440" marR="91440" marT="36576" marB="36576" anchor="ctr">
                     <a:lnL w="9525" cap="flat" cmpd="sng" algn="ctr">
                       <a:solidFill>
                         <a:srgbClr val="D5DEDC"/>
@@ -9243,14 +9724,14 @@
       </p:graphicFrame>
       <p:sp>
         <p:nvSpPr>
-          <p:cNvPr id="5" name="text-88"/>
+          <p:cNvPr id="5" name="text-96"/>
           <p:cNvSpPr txBox="1"/>
           <p:nvPr/>
         </p:nvSpPr>
         <p:spPr>
           <a:xfrm>
             <a:off x="457200" y="4572000"/>
-            <a:ext cx="7315200" cy="274320"/>
+            <a:ext cx="7680960" cy="274320"/>
           </a:xfrm>
           <a:prstGeom prst="rect">
             <a:avLst/>
@@ -9274,7 +9755,7 @@
                 <a:ea typeface="Calibri" pitchFamily="34" charset="-122"/>
                 <a:cs typeface="Calibri" pitchFamily="34" charset="-120"/>
               </a:rPr>
-              <a:t>Tutte su PostgreSQL reale, non in memoria.</a:t>
+              <a:t>Tutte su PostgreSQL e MongoDB reali, non in memoria. L'interfaccia non è ancora provata.</a:t>
             </a:r>
             <a:endParaRPr lang="en-US" sz="1200" dirty="0"/>
           </a:p>
@@ -9393,14 +9874,14 @@
       </p:sp>
       <p:sp>
         <p:nvSpPr>
-          <p:cNvPr id="4" name="card-89"/>
+          <p:cNvPr id="4" name="card-97"/>
           <p:cNvSpPr/>
           <p:nvPr/>
         </p:nvSpPr>
         <p:spPr>
           <a:xfrm>
-            <a:off x="457200" y="1234440"/>
-            <a:ext cx="8229600" cy="868680"/>
+            <a:off x="457200" y="1188720"/>
+            <a:ext cx="8229600" cy="777240"/>
           </a:xfrm>
           <a:prstGeom prst="rect">
             <a:avLst/>
@@ -9418,14 +9899,14 @@
       </p:sp>
       <p:sp>
         <p:nvSpPr>
-          <p:cNvPr id="5" name="text-90"/>
+          <p:cNvPr id="5" name="text-98"/>
           <p:cNvSpPr txBox="1"/>
           <p:nvPr/>
         </p:nvSpPr>
         <p:spPr>
           <a:xfrm>
-            <a:off x="685800" y="1325880"/>
-            <a:ext cx="7772400" cy="685800"/>
+            <a:off x="685800" y="1261872"/>
+            <a:ext cx="7772400" cy="640080"/>
           </a:xfrm>
           <a:prstGeom prst="rect">
             <a:avLst/>
@@ -9441,7 +9922,7 @@
               <a:buNone/>
             </a:pPr>
             <a:r>
-              <a:rPr lang="en-US" sz="2000" b="1" dirty="0">
+              <a:rPr lang="en-US" sz="1900" b="1" dirty="0">
                 <a:solidFill>
                   <a:schemeClr val="bg1"/>
                 </a:solidFill>
@@ -9451,20 +9932,20 @@
               </a:rPr>
               <a:t>I dati sintetici verificano il prototipo, ma non dimostrano benefici reali per il campus.</a:t>
             </a:r>
-            <a:endParaRPr lang="en-US" sz="2000" dirty="0"/>
-          </a:p>
-        </p:txBody>
-      </p:sp>
-      <p:sp>
-        <p:nvSpPr>
-          <p:cNvPr id="6" name="text-91"/>
+            <a:endParaRPr lang="en-US" sz="1900" dirty="0"/>
+          </a:p>
+        </p:txBody>
+      </p:sp>
+      <p:sp>
+        <p:nvSpPr>
+          <p:cNvPr id="6" name="text-99"/>
           <p:cNvSpPr txBox="1"/>
           <p:nvPr/>
         </p:nvSpPr>
         <p:spPr>
           <a:xfrm>
-            <a:off x="457200" y="2331720"/>
-            <a:ext cx="8229600" cy="2377440"/>
+            <a:off x="457200" y="2148840"/>
+            <a:ext cx="8229600" cy="2560320"/>
           </a:xfrm>
           <a:prstGeom prst="rect">
             <a:avLst/>
@@ -9478,13 +9959,13 @@
           <a:p>
             <a:pPr marL="342900" indent="-342900">
               <a:spcAft>
-                <a:spcPts val="800"/>
+                <a:spcPts val="600"/>
               </a:spcAft>
               <a:buSzPct val="100000"/>
               <a:buChar char="•"/>
             </a:pPr>
             <a:r>
-              <a:rPr lang="en-US" sz="1600" dirty="0">
+              <a:rPr lang="en-US" sz="1400" dirty="0">
                 <a:solidFill>
                   <a:schemeClr val="tx1"/>
                 </a:solidFill>
@@ -9492,20 +9973,20 @@
                 <a:ea typeface="Calibri" pitchFamily="34" charset="-122"/>
                 <a:cs typeface="Calibri" pitchFamily="34" charset="-120"/>
               </a:rPr>
-              <a:t>Concorrenza provata su un solo servizio e un solo database PostgreSQL; con più istanze va ripetuta</a:t>
-            </a:r>
-            <a:endParaRPr lang="en-US" sz="1600" dirty="0"/>
+              <a:t>Interfaccia non ancora provata su due sistemi operativi e su uno smartphone</a:t>
+            </a:r>
+            <a:endParaRPr lang="en-US" sz="1400" dirty="0"/>
           </a:p>
           <a:p>
             <a:pPr marL="342900" indent="-342900">
               <a:spcAft>
-                <a:spcPts val="800"/>
+                <a:spcPts val="600"/>
               </a:spcAft>
               <a:buSzPct val="100000"/>
               <a:buChar char="•"/>
             </a:pPr>
             <a:r>
-              <a:rPr lang="en-US" sz="1600" dirty="0">
+              <a:rPr lang="en-US" sz="1400" dirty="0">
                 <a:solidFill>
                   <a:schemeClr val="tx1"/>
                 </a:solidFill>
@@ -9513,20 +9994,20 @@
                 <a:ea typeface="Calibri" pitchFamily="34" charset="-122"/>
                 <a:cs typeface="Calibri" pitchFamily="34" charset="-120"/>
               </a:rPr>
-              <a:t>Aula mista: un fallimento in CI ancora in indagine, il tetto di capienza non è dimostrato in modo affidabile</a:t>
-            </a:r>
-            <a:endParaRPr lang="en-US" sz="1600" dirty="0"/>
+              <a:t>Concorrenza provata su un solo servizio e un solo database; con più istanze va ripetuta</a:t>
+            </a:r>
+            <a:endParaRPr lang="en-US" sz="1400" dirty="0"/>
           </a:p>
           <a:p>
             <a:pPr marL="342900" indent="-342900">
               <a:spcAft>
-                <a:spcPts val="800"/>
+                <a:spcPts val="600"/>
               </a:spcAft>
               <a:buSzPct val="100000"/>
               <a:buChar char="•"/>
             </a:pPr>
             <a:r>
-              <a:rPr lang="en-US" sz="1600" dirty="0">
+              <a:rPr lang="en-US" sz="1400" dirty="0">
                 <a:solidFill>
                   <a:schemeClr val="tx1"/>
                 </a:solidFill>
@@ -9534,20 +10015,20 @@
                 <a:ea typeface="Calibri" pitchFamily="34" charset="-122"/>
                 <a:cs typeface="Calibri" pitchFamily="34" charset="-120"/>
               </a:rPr>
-              <a:t>Email come file .eml, nessun invio reale</a:t>
-            </a:r>
-            <a:endParaRPr lang="en-US" sz="1600" dirty="0"/>
+              <a:t>Aula mista: un fallimento in CI visto una volta e non riprodotto; causa probabile, non dimostrata</a:t>
+            </a:r>
+            <a:endParaRPr lang="en-US" sz="1400" dirty="0"/>
           </a:p>
           <a:p>
             <a:pPr marL="342900" indent="-342900">
               <a:spcAft>
-                <a:spcPts val="800"/>
+                <a:spcPts val="600"/>
               </a:spcAft>
               <a:buSzPct val="100000"/>
               <a:buChar char="•"/>
             </a:pPr>
             <a:r>
-              <a:rPr lang="en-US" sz="1600" dirty="0">
+              <a:rPr lang="en-US" sz="1400" dirty="0">
                 <a:solidFill>
                   <a:schemeClr val="tx1"/>
                 </a:solidFill>
@@ -9555,20 +10036,41 @@
                 <a:ea typeface="Calibri" pitchFamily="34" charset="-122"/>
                 <a:cs typeface="Calibri" pitchFamily="34" charset="-120"/>
               </a:rPr>
-              <a:t>Prenotazioni già terminate non annullabili (scelta del gruppo, da confermare)</a:t>
-            </a:r>
-            <a:endParaRPr lang="en-US" sz="1600" dirty="0"/>
+              <a:t>Con PostgreSQL fermo Bookings risponde dopo circa un minuto: da correggere</a:t>
+            </a:r>
+            <a:endParaRPr lang="en-US" sz="1400" dirty="0"/>
           </a:p>
           <a:p>
             <a:pPr marL="342900" indent="-342900">
               <a:spcAft>
-                <a:spcPts val="800"/>
+                <a:spcPts val="600"/>
               </a:spcAft>
               <a:buSzPct val="100000"/>
               <a:buChar char="•"/>
             </a:pPr>
             <a:r>
-              <a:rPr lang="en-US" sz="1600" dirty="0">
+              <a:rPr lang="en-US" sz="1400" dirty="0">
+                <a:solidFill>
+                  <a:schemeClr val="tx1"/>
+                </a:solidFill>
+                <a:latin typeface="Calibri" pitchFamily="34" charset="0"/>
+                <a:ea typeface="Calibri" pitchFamily="34" charset="-122"/>
+                <a:cs typeface="Calibri" pitchFamily="34" charset="-120"/>
+              </a:rPr>
+              <a:t>Email in coda nel database: i file .eml arrivano con un task successivo</a:t>
+            </a:r>
+            <a:endParaRPr lang="en-US" sz="1400" dirty="0"/>
+          </a:p>
+          <a:p>
+            <a:pPr marL="342900" indent="-342900">
+              <a:spcAft>
+                <a:spcPts val="600"/>
+              </a:spcAft>
+              <a:buSzPct val="100000"/>
+              <a:buChar char="•"/>
+            </a:pPr>
+            <a:r>
+              <a:rPr lang="en-US" sz="1400" dirty="0">
                 <a:solidFill>
                   <a:schemeClr val="tx1"/>
                 </a:solidFill>
@@ -9578,7 +10080,7 @@
               </a:rPr>
               <a:t>Decisioni del PO ancora in attesa nel registro</a:t>
             </a:r>
-            <a:endParaRPr lang="en-US" sz="1600" dirty="0"/>
+            <a:endParaRPr lang="en-US" sz="1400" dirty="0"/>
           </a:p>
         </p:txBody>
       </p:sp>

</xml_diff>